<commit_message>
complete two-device manufacturing BOM
</commit_message>
<xml_diff>
--- a/hardware/presentation/vibekey-rev-a-bom.pptx
+++ b/hardware/presentation/vibekey-rev-a-bom.pptx
@@ -3514,7 +3514,7 @@
           <a:noFill/>
         </p:spPr>
         <p:txBody>
-          <a:bodyPr wrap="none">
+          <a:bodyPr wrap="square">
             <a:spAutoFit/>
           </a:bodyPr>
           <a:lstStyle/>
@@ -3686,7 +3686,7 @@
           <a:noFill/>
         </p:spPr>
         <p:txBody>
-          <a:bodyPr wrap="none">
+          <a:bodyPr wrap="square">
             <a:spAutoFit/>
           </a:bodyPr>
           <a:lstStyle/>
@@ -3858,7 +3858,7 @@
           <a:noFill/>
         </p:spPr>
         <p:txBody>
-          <a:bodyPr wrap="none">
+          <a:bodyPr wrap="square">
             <a:spAutoFit/>
           </a:bodyPr>
           <a:lstStyle/>
@@ -4238,7 +4238,7 @@
           <a:noFill/>
         </p:spPr>
         <p:txBody>
-          <a:bodyPr wrap="none">
+          <a:bodyPr wrap="square">
             <a:spAutoFit/>
           </a:bodyPr>
           <a:lstStyle/>
@@ -4402,7 +4402,7 @@
           <a:noFill/>
         </p:spPr>
         <p:txBody>
-          <a:bodyPr wrap="none">
+          <a:bodyPr wrap="square">
             <a:spAutoFit/>
           </a:bodyPr>
           <a:lstStyle/>
@@ -4566,7 +4566,7 @@
           <a:noFill/>
         </p:spPr>
         <p:txBody>
-          <a:bodyPr wrap="none">
+          <a:bodyPr wrap="square">
             <a:spAutoFit/>
           </a:bodyPr>
           <a:lstStyle/>
@@ -4730,7 +4730,7 @@
           <a:noFill/>
         </p:spPr>
         <p:txBody>
-          <a:bodyPr wrap="none">
+          <a:bodyPr wrap="square">
             <a:spAutoFit/>
           </a:bodyPr>
           <a:lstStyle/>
@@ -4898,7 +4898,7 @@
           <a:noFill/>
         </p:spPr>
         <p:txBody>
-          <a:bodyPr wrap="none">
+          <a:bodyPr wrap="square">
             <a:spAutoFit/>
           </a:bodyPr>
           <a:lstStyle/>
@@ -5062,7 +5062,7 @@
           <a:noFill/>
         </p:spPr>
         <p:txBody>
-          <a:bodyPr wrap="none">
+          <a:bodyPr wrap="square">
             <a:spAutoFit/>
           </a:bodyPr>
           <a:lstStyle/>
@@ -5395,7 +5395,7 @@
           <a:noFill/>
         </p:spPr>
         <p:txBody>
-          <a:bodyPr wrap="none">
+          <a:bodyPr wrap="square">
             <a:spAutoFit/>
           </a:bodyPr>
           <a:lstStyle/>
@@ -5567,7 +5567,7 @@
           <a:noFill/>
         </p:spPr>
         <p:txBody>
-          <a:bodyPr wrap="none">
+          <a:bodyPr wrap="square">
             <a:spAutoFit/>
           </a:bodyPr>
           <a:lstStyle/>
@@ -5739,7 +5739,7 @@
           <a:noFill/>
         </p:spPr>
         <p:txBody>
-          <a:bodyPr wrap="none">
+          <a:bodyPr wrap="square">
             <a:spAutoFit/>
           </a:bodyPr>
           <a:lstStyle/>
@@ -5778,8 +5778,8 @@
         </p:nvSpPr>
         <p:spPr>
           <a:xfrm>
-            <a:off x="914400" y="3977639"/>
-            <a:ext cx="10149840" cy="1463040"/>
+            <a:off x="914400" y="3840480"/>
+            <a:ext cx="10149840" cy="1737360"/>
           </a:xfrm>
           <a:prstGeom prst="rect">
             <a:avLst/>
@@ -5796,7 +5796,7 @@
               <a:spcAft>
                 <a:spcPts val="1100"/>
               </a:spcAft>
-              <a:defRPr sz="1700">
+              <a:defRPr sz="1600">
                 <a:solidFill>
                   <a:srgbClr val="191C24"/>
                 </a:solidFill>
@@ -5804,7 +5804,7 @@
               </a:defRPr>
             </a:pPr>
             <a:r>
-              <a:t>JLC may require attrition quantities for placement. Those are manufacturing consumables—not parts for a third device.</a:t>
+              <a:t>57 frozen BOM lines include per-board reference designators, fabricated parts, and reusable programming tools.</a:t>
             </a:r>
           </a:p>
           <a:p>
@@ -5812,7 +5812,23 @@
               <a:spcAft>
                 <a:spcPts val="1100"/>
               </a:spcAft>
-              <a:defRPr sz="1700">
+              <a:defRPr sz="1600">
+                <a:solidFill>
+                  <a:srgbClr val="191C24"/>
+                </a:solidFill>
+                <a:latin typeface="Avenir Next"/>
+              </a:defRPr>
+            </a:pPr>
+            <a:r>
+              <a:t>JLC attrition quantities are manufacturing consumables—not parts for a third device.</a:t>
+            </a:r>
+          </a:p>
+          <a:p>
+            <a:pPr>
+              <a:spcAft>
+                <a:spcPts val="1100"/>
+              </a:spcAft>
+              <a:defRPr sz="1600">
                 <a:solidFill>
                   <a:srgbClr val="191C24"/>
                 </a:solidFill>
@@ -6135,7 +6151,7 @@
           <a:noFill/>
         </p:spPr>
         <p:txBody>
-          <a:bodyPr wrap="none">
+          <a:bodyPr wrap="square">
             <a:spAutoFit/>
           </a:bodyPr>
           <a:lstStyle/>
@@ -6319,7 +6335,7 @@
           <a:noFill/>
         </p:spPr>
         <p:txBody>
-          <a:bodyPr wrap="none">
+          <a:bodyPr wrap="square">
             <a:spAutoFit/>
           </a:bodyPr>
           <a:lstStyle/>
@@ -6636,7 +6652,7 @@
           <a:noFill/>
         </p:spPr>
         <p:txBody>
-          <a:bodyPr wrap="none">
+          <a:bodyPr wrap="square">
             <a:spAutoFit/>
           </a:bodyPr>
           <a:lstStyle/>
@@ -6808,7 +6824,7 @@
           <a:noFill/>
         </p:spPr>
         <p:txBody>
-          <a:bodyPr wrap="none">
+          <a:bodyPr wrap="square">
             <a:spAutoFit/>
           </a:bodyPr>
           <a:lstStyle/>
@@ -6980,7 +6996,7 @@
           <a:noFill/>
         </p:spPr>
         <p:txBody>
-          <a:bodyPr wrap="none">
+          <a:bodyPr wrap="square">
             <a:spAutoFit/>
           </a:bodyPr>
           <a:lstStyle/>
@@ -7376,7 +7392,7 @@
           <a:noFill/>
         </p:spPr>
         <p:txBody>
-          <a:bodyPr wrap="none">
+          <a:bodyPr wrap="square">
             <a:spAutoFit/>
           </a:bodyPr>
           <a:lstStyle/>
@@ -7540,7 +7556,7 @@
           <a:noFill/>
         </p:spPr>
         <p:txBody>
-          <a:bodyPr wrap="none">
+          <a:bodyPr wrap="square">
             <a:spAutoFit/>
           </a:bodyPr>
           <a:lstStyle/>
@@ -7704,7 +7720,7 @@
           <a:noFill/>
         </p:spPr>
         <p:txBody>
-          <a:bodyPr wrap="none">
+          <a:bodyPr wrap="square">
             <a:spAutoFit/>
           </a:bodyPr>
           <a:lstStyle/>
@@ -8325,7 +8341,7 @@
           <a:noFill/>
         </p:spPr>
         <p:txBody>
-          <a:bodyPr wrap="none">
+          <a:bodyPr wrap="square">
             <a:spAutoFit/>
           </a:bodyPr>
           <a:lstStyle/>
@@ -8501,7 +8517,7 @@
           <a:noFill/>
         </p:spPr>
         <p:txBody>
-          <a:bodyPr wrap="none">
+          <a:bodyPr wrap="square">
             <a:spAutoFit/>
           </a:bodyPr>
           <a:lstStyle/>

</xml_diff>